<commit_message>
docs: team leader and deployment link in team sheet, shared presenter plan, full team info on title slide, README screenshots
</commit_message>
<xml_diff>
--- a/documentation/Week 13 Assignment — Presentation/CSE4204-8A-T05 Presentation.pptx
+++ b/documentation/Week 13 Assignment — Presentation/CSE4204-8A-T05 Presentation.pptx
@@ -122,40 +122,40 @@
   <p:extLst>
     <p:ext uri="{521415D9-36F7-43E2-AB2F-B90AF26B5E84}">
       <p14:sectionLst xmlns:p14="http://schemas.microsoft.com/office/powerpoint/2010/main">
-        <p14:section name="Introduction" id="{e1a2d5ab-2bff-432e-7acc-68c397deb5e9}">
+        <p14:section name="Introduction" id="{5fc29c1c-6de3-c43b-c8fb-44928bb49815}">
           <p14:sldIdLst>
             <p14:sldId id="256"/>
             <p14:sldId id="257"/>
             <p14:sldId id="258"/>
           </p14:sldIdLst>
         </p14:section>
-        <p14:section name="System" id="{3f019160-117d-37f5-a88d-7844025a96c7}">
+        <p14:section name="System" id="{0561cebf-8770-4f19-8a20-5236205138c7}">
           <p14:sldIdLst>
             <p14:sldId id="259"/>
             <p14:sldId id="260"/>
             <p14:sldId id="261"/>
           </p14:sldIdLst>
         </p14:section>
-        <p14:section name="AI" id="{d29edc36-1622-e1c8-61cb-1a932d05f090}">
+        <p14:section name="AI" id="{806ab706-c51d-b1d8-68a5-65c80c6143cf}">
           <p14:sldIdLst>
             <p14:sldId id="262"/>
             <p14:sldId id="263"/>
           </p14:sldIdLst>
         </p14:section>
-        <p14:section name="Quality" id="{769e7f7c-f30c-e6f1-6134-db5ae5c6b4d6}">
+        <p14:section name="Quality" id="{96fc849f-f8b1-1c5f-079c-ee7d03158538}">
           <p14:sldIdLst>
             <p14:sldId id="264"/>
             <p14:sldId id="265"/>
             <p14:sldId id="266"/>
           </p14:sldIdLst>
         </p14:section>
-        <p14:section name="Demonstration" id="{7cfda3e8-1c16-4e6c-af8f-f27abc30b29e}">
+        <p14:section name="Demonstration" id="{7b461ffb-9dd2-441c-b072-2f3742201b68}">
           <p14:sldIdLst>
             <p14:sldId id="267"/>
             <p14:sldId id="268"/>
           </p14:sldIdLst>
         </p14:section>
-        <p14:section name="Conclusion" id="{35dfc9df-762f-b246-d39d-8d45d50bd6ea}">
+        <p14:section name="Conclusion" id="{5b773bfc-1503-ceb3-9055-74688c4a9891}">
           <p14:sldIdLst>
             <p14:sldId id="269"/>
             <p14:sldId id="270"/>
@@ -1100,7 +1100,7 @@
           <a:p>
             <a:r>
               <a:rPr lang="en-US" dirty="0"/>
-              <a:t>Now we show the system live. Backup: if the network or Gemini fails, the next slide has screenshots of every step, and the demo account already contains a finished analysis.</a:t>
+              <a:t>Now we show the system live. Each member demonstrates the part they built: Ratul authentication, Sakib upload, analysis and Europass, Mahammad editing, scoring and the cover letter, Himel the dashboard and tests. Backup: if the network or Gemini fails, the next slide has screenshots of every step, and the demo account already contains a finished analysis.</a:t>
             </a:r>
             <a:endParaRPr lang="en-US" dirty="0"/>
           </a:p>
@@ -2262,7 +2262,7 @@
         </p:nvSpPr>
         <p:spPr>
           <a:xfrm>
-            <a:off x="640080" y="1920240"/>
+            <a:off x="640080" y="1645920"/>
             <a:ext cx="6949440" cy="1280160"/>
           </a:xfrm>
           <a:prstGeom prst="rect">
@@ -2301,7 +2301,7 @@
         </p:nvSpPr>
         <p:spPr>
           <a:xfrm>
-            <a:off x="640080" y="3291840"/>
+            <a:off x="640080" y="3017520"/>
             <a:ext cx="6949440" cy="914400"/>
           </a:xfrm>
           <a:prstGeom prst="rect">
@@ -3018,7 +3018,7 @@
         </p:nvSpPr>
         <p:spPr>
           <a:xfrm>
-            <a:off x="640080" y="1920240"/>
+            <a:off x="640080" y="1645920"/>
             <a:ext cx="6949440" cy="1280160"/>
           </a:xfrm>
           <a:prstGeom prst="rect">
@@ -3056,7 +3056,7 @@
         </p:nvSpPr>
         <p:spPr>
           <a:xfrm>
-            <a:off x="640080" y="3291840"/>
+            <a:off x="640080" y="3017520"/>
             <a:ext cx="6949440" cy="914400"/>
           </a:xfrm>
           <a:prstGeom prst="rect">
@@ -3092,8 +3092,8 @@
         </p:nvSpPr>
         <p:spPr>
           <a:xfrm>
-            <a:off x="640080" y="4800600"/>
-            <a:ext cx="7315200" cy="1188720"/>
+            <a:off x="640080" y="4434840"/>
+            <a:ext cx="7680960" cy="1920240"/>
           </a:xfrm>
           <a:prstGeom prst="rect">
             <a:avLst/>
@@ -3112,7 +3112,7 @@
               <a:buNone/>
             </a:pPr>
             <a:r>
-              <a:rPr lang="en-US" sz="1400" dirty="0">
+              <a:rPr lang="en-US" sz="1400" b="1" dirty="0">
                 <a:solidFill>
                   <a:schemeClr val="bg1"/>
                 </a:solidFill>
@@ -3134,7 +3134,41 @@
                   <a:schemeClr val="bg1"/>
                 </a:solidFill>
               </a:rPr>
-              <a:t>Mahammad Hasan · Shanawaz Sakib · Ashikur Rahman Himel · Rasel Ratul</a:t>
+              <a:t>Team Leader: Mahammad Hasan (11220320828)</a:t>
+            </a:r>
+            <a:endParaRPr lang="en-US" sz="1400" dirty="0"/>
+          </a:p>
+          <a:p>
+            <a:pPr indent="0" marL="0">
+              <a:spcAft>
+                <a:spcPts val="600"/>
+              </a:spcAft>
+              <a:buNone/>
+            </a:pPr>
+            <a:r>
+              <a:rPr lang="en-US" sz="1400" dirty="0">
+                <a:solidFill>
+                  <a:schemeClr val="bg1"/>
+                </a:solidFill>
+              </a:rPr>
+              <a:t>Shanawaz Sakib (11220320916) · Ashikur Rahman Himel (11220320833) · Rasel Ratul (11220320827)</a:t>
+            </a:r>
+            <a:endParaRPr lang="en-US" sz="1400" dirty="0"/>
+          </a:p>
+          <a:p>
+            <a:pPr indent="0" marL="0">
+              <a:spcAft>
+                <a:spcPts val="600"/>
+              </a:spcAft>
+              <a:buNone/>
+            </a:pPr>
+            <a:r>
+              <a:rPr lang="en-US" sz="1400" dirty="0">
+                <a:solidFill>
+                  <a:schemeClr val="bg1"/>
+                </a:solidFill>
+              </a:rPr>
+              <a:t>GitHub: github.com/mahamud894/AI_Resume_Analyzer</a:t>
             </a:r>
             <a:endParaRPr lang="en-US" sz="1400" dirty="0"/>
           </a:p>

</xml_diff>

<commit_message>
docs: redesigned architecture, ERD, AI workflow and auth diagrams
</commit_message>
<xml_diff>
--- a/documentation/Week 13 Assignment — Presentation/CSE4204-8A-T05 Presentation.pptx
+++ b/documentation/Week 13 Assignment — Presentation/CSE4204-8A-T05 Presentation.pptx
@@ -122,40 +122,40 @@
   <p:extLst>
     <p:ext uri="{521415D9-36F7-43E2-AB2F-B90AF26B5E84}">
       <p14:sectionLst xmlns:p14="http://schemas.microsoft.com/office/powerpoint/2010/main">
-        <p14:section name="Introduction" id="{5fc29c1c-6de3-c43b-c8fb-44928bb49815}">
+        <p14:section name="Introduction" id="{3cb5eac3-c6fb-eb64-927c-7b816d4774f1}">
           <p14:sldIdLst>
             <p14:sldId id="256"/>
             <p14:sldId id="257"/>
             <p14:sldId id="258"/>
           </p14:sldIdLst>
         </p14:section>
-        <p14:section name="System" id="{0561cebf-8770-4f19-8a20-5236205138c7}">
+        <p14:section name="System" id="{3e934ac8-6da5-075f-4565-fc27f88816fc}">
           <p14:sldIdLst>
             <p14:sldId id="259"/>
             <p14:sldId id="260"/>
             <p14:sldId id="261"/>
           </p14:sldIdLst>
         </p14:section>
-        <p14:section name="AI" id="{806ab706-c51d-b1d8-68a5-65c80c6143cf}">
+        <p14:section name="AI" id="{f18f98c4-f090-5c48-28e0-7cc0119dfa8e}">
           <p14:sldIdLst>
             <p14:sldId id="262"/>
             <p14:sldId id="263"/>
           </p14:sldIdLst>
         </p14:section>
-        <p14:section name="Quality" id="{96fc849f-f8b1-1c5f-079c-ee7d03158538}">
+        <p14:section name="Quality" id="{ce617366-0068-6c20-586f-3c7ba21dceec}">
           <p14:sldIdLst>
             <p14:sldId id="264"/>
             <p14:sldId id="265"/>
             <p14:sldId id="266"/>
           </p14:sldIdLst>
         </p14:section>
-        <p14:section name="Demonstration" id="{7b461ffb-9dd2-441c-b072-2f3742201b68}">
+        <p14:section name="Demonstration" id="{a6fd0b4d-51d0-7640-3dd1-377569c4992a}">
           <p14:sldIdLst>
             <p14:sldId id="267"/>
             <p14:sldId id="268"/>
           </p14:sldIdLst>
         </p14:section>
-        <p14:section name="Conclusion" id="{5b773bfc-1503-ceb3-9055-74688c4a9891}">
+        <p14:section name="Conclusion" id="{c6fd3597-03e0-ef77-6a36-b52a14652ca8}">
           <p14:sldIdLst>
             <p14:sldId id="269"/>
             <p14:sldId id="270"/>
@@ -11758,8 +11758,8 @@
         </p:blipFill>
         <p:spPr>
           <a:xfrm>
-            <a:off x="843185" y="1234440"/>
-            <a:ext cx="10475150" cy="3931920"/>
+            <a:off x="2526691" y="1234440"/>
+            <a:ext cx="7108139" cy="3931920"/>
           </a:xfrm>
           <a:prstGeom prst="rect">
             <a:avLst/>
@@ -12106,8 +12106,8 @@
         </p:blipFill>
         <p:spPr>
           <a:xfrm>
-            <a:off x="548640" y="1698009"/>
-            <a:ext cx="6949440" cy="4010622"/>
+            <a:off x="548640" y="1789723"/>
+            <a:ext cx="6949440" cy="3827194"/>
           </a:xfrm>
           <a:prstGeom prst="rect">
             <a:avLst/>

</xml_diff>

<commit_message>
docs: final polish of Week 11-14 documents and slides
</commit_message>
<xml_diff>
--- a/documentation/Week 13 Assignment — Presentation/CSE4204-8A-T05 Presentation.pptx
+++ b/documentation/Week 13 Assignment — Presentation/CSE4204-8A-T05 Presentation.pptx
@@ -122,40 +122,40 @@
   <p:extLst>
     <p:ext uri="{521415D9-36F7-43E2-AB2F-B90AF26B5E84}">
       <p14:sectionLst xmlns:p14="http://schemas.microsoft.com/office/powerpoint/2010/main">
-        <p14:section name="Introduction" id="{3cb5eac3-c6fb-eb64-927c-7b816d4774f1}">
+        <p14:section name="Introduction" id="{a588aee2-0f89-216e-a74e-2f7783782956}">
           <p14:sldIdLst>
             <p14:sldId id="256"/>
             <p14:sldId id="257"/>
             <p14:sldId id="258"/>
           </p14:sldIdLst>
         </p14:section>
-        <p14:section name="System" id="{3e934ac8-6da5-075f-4565-fc27f88816fc}">
+        <p14:section name="System" id="{e3cadbda-d81a-6b80-8fe7-5ef3231911e0}">
           <p14:sldIdLst>
             <p14:sldId id="259"/>
             <p14:sldId id="260"/>
             <p14:sldId id="261"/>
           </p14:sldIdLst>
         </p14:section>
-        <p14:section name="AI" id="{f18f98c4-f090-5c48-28e0-7cc0119dfa8e}">
+        <p14:section name="AI" id="{9a830e5e-4dbc-e0a8-9b3c-cb6c19b050ac}">
           <p14:sldIdLst>
             <p14:sldId id="262"/>
             <p14:sldId id="263"/>
           </p14:sldIdLst>
         </p14:section>
-        <p14:section name="Quality" id="{ce617366-0068-6c20-586f-3c7ba21dceec}">
+        <p14:section name="Quality" id="{b9f7e1ea-1ce5-7c3a-5222-818112066573}">
           <p14:sldIdLst>
             <p14:sldId id="264"/>
             <p14:sldId id="265"/>
             <p14:sldId id="266"/>
           </p14:sldIdLst>
         </p14:section>
-        <p14:section name="Demonstration" id="{a6fd0b4d-51d0-7640-3dd1-377569c4992a}">
+        <p14:section name="Demonstration" id="{894d987c-f4aa-586e-8795-91b72b7ee460}">
           <p14:sldIdLst>
             <p14:sldId id="267"/>
             <p14:sldId id="268"/>
           </p14:sldIdLst>
         </p14:section>
-        <p14:section name="Conclusion" id="{c6fd3597-03e0-ef77-6a36-b52a14652ca8}">
+        <p14:section name="Conclusion" id="{0013e30e-cbda-58b2-f93a-88e8c3f688e5}">
           <p14:sldIdLst>
             <p14:sldId id="269"/>
             <p14:sldId id="270"/>
@@ -5848,8 +5848,8 @@
         </p:blipFill>
         <p:spPr>
           <a:xfrm>
-            <a:off x="1549908" y="1234440"/>
-            <a:ext cx="3438144" cy="2148840"/>
+            <a:off x="1440180" y="1188720"/>
+            <a:ext cx="3657600" cy="2286000"/>
           </a:xfrm>
           <a:prstGeom prst="rect">
             <a:avLst/>
@@ -5871,8 +5871,8 @@
         </p:nvSpPr>
         <p:spPr>
           <a:xfrm>
-            <a:off x="548640" y="3447288"/>
-            <a:ext cx="5440680" cy="274320"/>
+            <a:off x="548640" y="3502152"/>
+            <a:ext cx="5440680" cy="256032"/>
           </a:xfrm>
           <a:prstGeom prst="rect">
             <a:avLst/>
@@ -5915,8 +5915,8 @@
         </p:blipFill>
         <p:spPr>
           <a:xfrm>
-            <a:off x="7127748" y="1234440"/>
-            <a:ext cx="3438144" cy="2148840"/>
+            <a:off x="7018020" y="1188720"/>
+            <a:ext cx="3657600" cy="2286000"/>
           </a:xfrm>
           <a:prstGeom prst="rect">
             <a:avLst/>
@@ -5938,8 +5938,8 @@
         </p:nvSpPr>
         <p:spPr>
           <a:xfrm>
-            <a:off x="6126480" y="3447288"/>
-            <a:ext cx="5440680" cy="274320"/>
+            <a:off x="6126480" y="3502152"/>
+            <a:ext cx="5440680" cy="256032"/>
           </a:xfrm>
           <a:prstGeom prst="rect">
             <a:avLst/>
@@ -5982,8 +5982,8 @@
         </p:blipFill>
         <p:spPr>
           <a:xfrm>
-            <a:off x="1549908" y="3840480"/>
-            <a:ext cx="3438144" cy="2148840"/>
+            <a:off x="1440180" y="3794760"/>
+            <a:ext cx="3657600" cy="2286000"/>
           </a:xfrm>
           <a:prstGeom prst="rect">
             <a:avLst/>
@@ -6005,8 +6005,8 @@
         </p:nvSpPr>
         <p:spPr>
           <a:xfrm>
-            <a:off x="548640" y="6053328"/>
-            <a:ext cx="5440680" cy="274320"/>
+            <a:off x="548640" y="6108192"/>
+            <a:ext cx="5440680" cy="256032"/>
           </a:xfrm>
           <a:prstGeom prst="rect">
             <a:avLst/>
@@ -6049,8 +6049,8 @@
         </p:blipFill>
         <p:spPr>
           <a:xfrm>
-            <a:off x="7127748" y="3840480"/>
-            <a:ext cx="3438144" cy="2148840"/>
+            <a:off x="7018020" y="3794760"/>
+            <a:ext cx="3657600" cy="2286000"/>
           </a:xfrm>
           <a:prstGeom prst="rect">
             <a:avLst/>
@@ -6072,8 +6072,8 @@
         </p:nvSpPr>
         <p:spPr>
           <a:xfrm>
-            <a:off x="6126480" y="6053328"/>
-            <a:ext cx="5440680" cy="274320"/>
+            <a:off x="6126480" y="6108192"/>
+            <a:ext cx="5440680" cy="256032"/>
           </a:xfrm>
           <a:prstGeom prst="rect">
             <a:avLst/>
@@ -11758,8 +11758,8 @@
         </p:blipFill>
         <p:spPr>
           <a:xfrm>
-            <a:off x="2526691" y="1234440"/>
-            <a:ext cx="7108139" cy="3931920"/>
+            <a:off x="457200" y="1450048"/>
+            <a:ext cx="8229600" cy="4552265"/>
           </a:xfrm>
           <a:prstGeom prst="rect">
             <a:avLst/>
@@ -11774,12 +11774,12 @@
         </p:nvSpPr>
         <p:spPr>
           <a:xfrm>
-            <a:off x="548640" y="5303520"/>
-            <a:ext cx="3520440" cy="914400"/>
+            <a:off x="8915400" y="1371600"/>
+            <a:ext cx="2697480" cy="1417320"/>
           </a:xfrm>
           <a:prstGeom prst="roundRect">
             <a:avLst>
-              <a:gd name="adj" fmla="val 12000"/>
+              <a:gd name="adj" fmla="val 7742"/>
             </a:avLst>
           </a:prstGeom>
           <a:solidFill>
@@ -11796,8 +11796,8 @@
         </p:nvSpPr>
         <p:spPr>
           <a:xfrm>
-            <a:off x="731520" y="5376672"/>
-            <a:ext cx="3200400" cy="777240"/>
+            <a:off x="9098280" y="1508760"/>
+            <a:ext cx="2377440" cy="1188720"/>
           </a:xfrm>
           <a:prstGeom prst="rect">
             <a:avLst/>
@@ -11846,12 +11846,12 @@
         </p:nvSpPr>
         <p:spPr>
           <a:xfrm>
-            <a:off x="4297680" y="5303520"/>
-            <a:ext cx="3520440" cy="914400"/>
+            <a:off x="8915400" y="2971800"/>
+            <a:ext cx="2697480" cy="1417320"/>
           </a:xfrm>
           <a:prstGeom prst="roundRect">
             <a:avLst>
-              <a:gd name="adj" fmla="val 12000"/>
+              <a:gd name="adj" fmla="val 7742"/>
             </a:avLst>
           </a:prstGeom>
           <a:solidFill>
@@ -11868,8 +11868,8 @@
         </p:nvSpPr>
         <p:spPr>
           <a:xfrm>
-            <a:off x="4480560" y="5376672"/>
-            <a:ext cx="3200400" cy="777240"/>
+            <a:off x="9098280" y="3108960"/>
+            <a:ext cx="2377440" cy="1188720"/>
           </a:xfrm>
           <a:prstGeom prst="rect">
             <a:avLst/>
@@ -11918,12 +11918,12 @@
         </p:nvSpPr>
         <p:spPr>
           <a:xfrm>
-            <a:off x="8046720" y="5303520"/>
-            <a:ext cx="3520440" cy="914400"/>
+            <a:off x="8915400" y="4572000"/>
+            <a:ext cx="2697480" cy="1417320"/>
           </a:xfrm>
           <a:prstGeom prst="roundRect">
             <a:avLst>
-              <a:gd name="adj" fmla="val 12000"/>
+              <a:gd name="adj" fmla="val 7742"/>
             </a:avLst>
           </a:prstGeom>
           <a:solidFill>
@@ -11940,8 +11940,8 @@
         </p:nvSpPr>
         <p:spPr>
           <a:xfrm>
-            <a:off x="8229600" y="5376672"/>
-            <a:ext cx="3200400" cy="777240"/>
+            <a:off x="9098280" y="4709160"/>
+            <a:ext cx="2377440" cy="1188720"/>
           </a:xfrm>
           <a:prstGeom prst="rect">
             <a:avLst/>

</xml_diff>